<commit_message>
:pencil: Small fix lecture 5
</commit_message>
<xml_diff>
--- a/lessons/lesson05_research_grade_ml/theory/slides/Lecture5 - Research-Grade Machine Learning.pptx
+++ b/lessons/lesson05_research_grade_ml/theory/slides/Lecture5 - Research-Grade Machine Learning.pptx
@@ -507,7 +507,7 @@
           <a:p>
             <a:r>
               <a:rPr lang="en-US" dirty="0"/>
-              <a:t>1 min. The shift in perspective: for four lectures you were the builder; today you become the judge. The skill that separates a publishable biomarker from the thousands that fail is demonstrating trust, not a cleverer algorithm.</a:t>
+              <a:t>Today -&gt; judging model -&gt; make sure it survives the after publication validation </a:t>
             </a:r>
           </a:p>
         </p:txBody>
@@ -594,7 +594,7 @@
           <a:p>
             <a:r>
               <a:rPr lang="en-US" dirty="0"/>
-              <a:t>5 min. Covariate: feature distributions differ (new platform, younger cohort). Label: outcome frequency differs (screening cohort, fewer recurrences). Concept: the feature-&gt;outcome relationship itself changes (new standard of care) -- can invalidate the biomarker entirely.</a:t>
+              <a:t>Describe thoroughly 1 -&gt; 2 -&gt; 3</a:t>
             </a:r>
           </a:p>
         </p:txBody>
@@ -681,7 +681,7 @@
           <a:p>
             <a:r>
               <a:rPr lang="en-US" dirty="0"/>
-              <a:t>5 min. All course long we simplified time-to-event recurrence into a binary label -- a deliberate teaching choice. Real outcomes are time-to-event with censoring. Survival models (Cox, conceptually) use the time axis. The validation discipline still applies; the outcome is just richer and more honest.</a:t>
+              <a:t>Just a quick note -&gt; 1 -&gt; 2 -&gt; comment figure KM -&gt; 3 -&gt; 4 </a:t>
             </a:r>
           </a:p>
         </p:txBody>
@@ -768,7 +768,7 @@
           <a:p>
             <a:r>
               <a:rPr lang="en-US" dirty="0"/>
-              <a:t>4 min. Computational: can someone rerun your analysis and get your numbers? Scientific (replication): can someone reproduce your finding in new data? Different bars -- passing the first does not guarantee the second. Most published work falls short of even the first.</a:t>
+              <a:t>1 -&gt; 2 -&gt; 3 -&gt; 4</a:t>
             </a:r>
           </a:p>
         </p:txBody>
@@ -855,7 +855,7 @@
           <a:p>
             <a:r>
               <a:rPr lang="en-US" dirty="0"/>
-              <a:t>4 min. Seeds; encapsulated pipelines (refit inside CV); version &amp; environment capture; documentation; open science (code, data where possible, model/spec). Callback (L4): reproducibility is self-defense -- it catches your own leakage before a reviewer.</a:t>
+              <a:t>Recall</a:t>
             </a:r>
           </a:p>
         </p:txBody>
@@ -942,7 +942,7 @@
           <a:p>
             <a:r>
               <a:rPr lang="en-US" dirty="0"/>
-              <a:t>5 min. A biomarker can be highly significant and clinically useless. Significance: 'an association exists.' Utility: 'does it change a decision and help a patient?' A tiny HR with a vanishing p-value (large n) may move no decision. Ask: actionability, effect size, added value.</a:t>
+              <a:t>Most important part. 1 -&gt; very often significance is enough for paper. But for clinics not. -&gt; 2 -&gt; 3 -&gt; example in 4</a:t>
             </a:r>
           </a:p>
         </p:txBody>
@@ -1029,7 +1029,7 @@
           <a:p>
             <a:r>
               <a:rPr lang="en-US" dirty="0"/>
-              <a:t>4 min. Actionability (changes management). Incremental value (beats grade/stage/nodal/Ki-67). Net benefit at a usable threshold. A biomarker that doesn't beat tumour grade and isn't actionable won't -- and shouldn't -- be adopted.</a:t>
+              <a:t>How do we define more rigorously actionability?</a:t>
             </a:r>
           </a:p>
         </p:txBody>
@@ -1114,10 +1114,7 @@
           <a:bodyPr/>
           <a:lstStyle/>
           <a:p>
-            <a:r>
-              <a:rPr lang="en-US" dirty="0"/>
-              <a:t>5 min. Each is an EVIDENCE failure, not an algorithm failure -- the course thesis again. Criticism -&gt; why it matters -&gt; how to avoid.</a:t>
-            </a:r>
+            <a:endParaRPr lang="en-US" dirty="0"/>
           </a:p>
         </p:txBody>
       </p:sp>
@@ -1203,7 +1200,7 @@
           <a:p>
             <a:r>
               <a:rPr lang="en-US" dirty="0"/>
-              <a:t>4 min. Run this on any transcriptomic ML paper. Task &amp; n? Validation appropriate (external?)? Leakage avoided (order of operations)? Reproducible (code/data/seeds)? Conclusions justified? Full version is the reviewer checklist handout.</a:t>
+              <a:t>Questions to ask yourself</a:t>
             </a:r>
           </a:p>
         </p:txBody>
@@ -1288,10 +1285,7 @@
           <a:bodyPr/>
           <a:lstStyle/>
           <a:p>
-            <a:r>
-              <a:rPr lang="en-US" dirty="0"/>
-              <a:t>4 min. Brief, non-technical. Deep learning (powerful with big data; in pn shares/amplifies pitfalls). Foundation models (validation rules unchanged). Multi-omics integration. Spatial omics. Precision oncology. Banner: the validation rules don't change.</a:t>
-            </a:r>
+            <a:endParaRPr lang="en-US" dirty="0"/>
           </a:p>
         </p:txBody>
       </p:sp>
@@ -1375,10 +1369,7 @@
           <a:bodyPr/>
           <a:lstStyle/>
           <a:p>
-            <a:r>
-              <a:rPr lang="en-US" dirty="0"/>
-              <a:t>4 min. Question -&gt; Data -&gt; Baseline -&gt; Features -&gt; Model selection -&gt; Validation -&gt; Interpretation -&gt; Publication. Each stage had a lecture and a failure mode. Trustworthiness is built in at every stage, not bolted on. This pipeline IS the course.</a:t>
-            </a:r>
+            <a:endParaRPr lang="en-US" dirty="0"/>
           </a:p>
         </p:txBody>
       </p:sp>
@@ -1464,7 +1455,7 @@
           <a:p>
             <a:r>
               <a:rPr lang="en-US" dirty="0"/>
-              <a:t>2 min. Trustworthy problem (L1), model (L2), features (L3), improvement &amp; honest validation (L4). You can build and evaluate a model. The hardest thing left: judging whether it is trustworthy and publication-ready. Today: everything that can go wrong, and how to catch it. You move to the reviewer's chair.</a:t>
+              <a:t>Recap 1 -&gt; 2 -&gt; 3 -&gt; 4 (we touched here and there in the 4 lectures but today we go through it)</a:t>
             </a:r>
           </a:p>
         </p:txBody>
@@ -1549,10 +1540,7 @@
           <a:bodyPr/>
           <a:lstStyle/>
           <a:p>
-            <a:r>
-              <a:rPr lang="en-US" dirty="0"/>
-              <a:t>2 min. Deliver the thesis with full weight. Corollaries: failures occur after development; validation &gt; optimization; reproducibility is essential; skepticism is healthy. The empowering close: you can now build, evaluate, AND review.</a:t>
-            </a:r>
+            <a:endParaRPr lang="en-US" dirty="0"/>
           </a:p>
         </p:txBody>
       </p:sp>
@@ -1636,10 +1624,7 @@
           <a:bodyPr/>
           <a:lstStyle/>
           <a:p>
-            <a:r>
-              <a:rPr lang="en-US" dirty="0"/>
-              <a:t>3 min. Tick objectives. Capstone: receive a FLAWED biomarker analysis, diagnose its flaws (leakage, no external validation, bad preprocessing, overfitting, unsupported interpretation), build a corrected workflow, compare honestly, and WRITE A REVIEWER REPORT with a publish/revise/reject recommendation. You leave able to build, evaluate, review, and design.</a:t>
-            </a:r>
+            <a:endParaRPr lang="en-US" dirty="0"/>
           </a:p>
         </p:txBody>
       </p:sp>
@@ -1723,10 +1708,7 @@
           <a:bodyPr/>
           <a:lstStyle/>
           <a:p>
-            <a:r>
-              <a:rPr lang="en-US" dirty="0"/>
-              <a:t>2 min. Close the course. Name the through-line; leave the durable charge. The judgment built here outlasts any algorithm. Thank them.</a:t>
-            </a:r>
+            <a:endParaRPr lang="en-US" dirty="0"/>
           </a:p>
         </p:txBody>
       </p:sp>
@@ -1812,7 +1794,7 @@
           <a:p>
             <a:r>
               <a:rPr lang="en-US" dirty="0"/>
-              <a:t>2 min. Flag the lecture-defining ones: external validation &amp; generalization, exploratory vs confirmatory, and significance vs clinical utility. The deliverable: by the end you can sit in the reviewer's chair.</a:t>
+              <a:t>Most important are generalization and in our field statistical significance and its difference with clinical utility</a:t>
             </a:r>
           </a:p>
         </p:txBody>
@@ -1899,7 +1881,7 @@
           <a:p>
             <a:r>
               <a:rPr lang="en-US" dirty="0"/>
-              <a:t>4 min. Provocative open: thousands of signatures published, a tiny fraction used clinically. Why? Usually not bad biology -- the EVIDENCE was never trustworthy. The failures are predictable, and almost all happen AFTER model development.</a:t>
+              <a:t>1 -&gt; figure on the right (it’s a bottle neck of filters) -&gt; one could say biology is wrong -&gt; 2  (in breast cancer only handful managed to get clinics) -&gt; 3</a:t>
             </a:r>
           </a:p>
         </p:txBody>
@@ -1986,7 +1968,24 @@
           <a:p>
             <a:r>
               <a:rPr lang="en-US" dirty="0"/>
-              <a:t>4 min. Each is a callback and a forward-link. None is about a bad algorithm -- they are evidence failures. Overfitting (L2), small cohorts/pn (L1), dataset bias/batch (L4), no external validation (today), publication bias (the field, not the paper).</a:t>
+              <a:t>The 5 recurring reason of failures: 1 (describe, improve with regularization or simpler model or more data) -&gt; 2 (we should validate with more data) -&gt; 3 (assuming correct normalization, but not -&gt; better implement it in the pipeline) -&gt; 4 (only on hold out same cohort test) -&gt; 5 -&gt; question (answer 5).</a:t>
+            </a:r>
+          </a:p>
+          <a:p>
+            <a:endParaRPr lang="en-US" dirty="0"/>
+          </a:p>
+          <a:p>
+            <a:r>
+              <a:rPr lang="en-US" dirty="0"/>
+              <a:t>Let’s start with validation and why </a:t>
+            </a:r>
+            <a:r>
+              <a:rPr lang="en-US" dirty="0" err="1"/>
+              <a:t>ext</a:t>
+            </a:r>
+            <a:r>
+              <a:rPr lang="en-US" dirty="0"/>
+              <a:t> is so important</a:t>
             </a:r>
           </a:p>
         </p:txBody>
@@ -2073,7 +2072,15 @@
           <a:p>
             <a:r>
               <a:rPr lang="en-US" dirty="0"/>
-              <a:t>4 min. Re-anchor the ladder: split -&gt; CV -&gt; nested CV. Each answers 'how well does this pipeline do on data LIKE THIS?' Done right it controls overfitting and tuning optimism. But every rung stays inside the original cohort.</a:t>
+              <a:t>Before </a:t>
+            </a:r>
+            <a:r>
+              <a:rPr lang="en-US" dirty="0" err="1"/>
+              <a:t>ext</a:t>
+            </a:r>
+            <a:r>
+              <a:rPr lang="en-US" dirty="0"/>
+              <a:t> validation -&gt; title -&gt; 1 -&gt; 2 -&gt; 3 -&gt; 4 (unless you used the external as test)</a:t>
             </a:r>
           </a:p>
         </p:txBody>
@@ -2160,7 +2167,15 @@
           <a:p>
             <a:r>
               <a:rPr lang="en-US" dirty="0"/>
-              <a:t>5 min. Validate on a DIFFERENT cohort -- hospital, study, population, platform. Closest thing to truth before a trial; tests generalization, not memorization. METABRIC (Illumina) -&gt; GSE6532 (Affymetrix). A model that holds across cohorts has earned a claim.</a:t>
+              <a:t>External validation -&gt; 1 (definition) -&gt; 2 ( since trials are expensive, we </a:t>
+            </a:r>
+            <a:r>
+              <a:rPr lang="en-US" dirty="0" err="1"/>
+              <a:t>wanna</a:t>
+            </a:r>
+            <a:r>
+              <a:rPr lang="en-US" dirty="0"/>
+              <a:t> make sure beforehand) -&gt; 3 (our system) -&gt; 4 -&gt; 5</a:t>
             </a:r>
           </a:p>
         </p:txBody>
@@ -2247,7 +2262,7 @@
           <a:p>
             <a:r>
               <a:rPr lang="en-US" dirty="0"/>
-              <a:t>4 min. It exposes what internal hides: batch, cohort quirks, leakage that survived CV. Performance almost always drops -- report how much. 'Validated' should mean externally validated. Beware re-tuning until a signature 'passes' -- that's a second training set.</a:t>
+              <a:t>Title -&gt; 1 (batch effects because single cohort in CV, survived CV for instance patient longitudinal data leakage) -&gt; 2 -&gt; 3 -&gt; 4 -&gt; figure</a:t>
             </a:r>
           </a:p>
         </p:txBody>
@@ -2334,7 +2349,7 @@
           <a:p>
             <a:r>
               <a:rPr lang="en-US" dirty="0"/>
-              <a:t>5 min. Models assume the deployment world looks like the training world -- often it doesn't. Distribution shift: the data distribution changes between development and deployment. Sources: population, treatment, platform, lab. The external drop isn't bad luck -- it's a real change in the data.</a:t>
+              <a:t>Title -&gt;Dataset shift -&gt; happens more often. -&gt; 1 -&gt; 2 -&gt; 3 -&gt; 4 (MORE INFO IN THE NEXT SLIDE)</a:t>
             </a:r>
           </a:p>
         </p:txBody>
@@ -16670,7 +16685,7 @@
                 <a:ea typeface="Calibri" pitchFamily="34" charset="-122"/>
                 <a:cs typeface="Calibri" pitchFamily="34" charset="-120"/>
               </a:rPr>
-              <a:t>The failures are predictable, and almost all happen after model development.</a:t>
+              <a:t>The failures are predictable, and almost all happen outside the model.</a:t>
             </a:r>
             <a:endParaRPr lang="en-US" sz="1550" dirty="0"/>
           </a:p>

</xml_diff>